<commit_message>
docs: atualiza README, diagrama de componentes e slides com a nova estrutura de pastas
</commit_message>
<xml_diff>
--- a/docs/apresentacao/Lab03S03-Apresentacao.pptx
+++ b/docs/apresentacao/Lab03S03-Apresentacao.pptx
@@ -135,7 +135,7 @@
   <p:extLst>
     <p:ext uri="{521415D9-36F7-43E2-AB2F-B90AF26B5E84}">
       <p14:sectionLst xmlns:p14="http://schemas.microsoft.com/office/powerpoint/2010/main">
-        <p14:section name="O trabalho" id="{67d722b9-4b64-7d5f-0174-b8c982d65f43}">
+        <p14:section name="O trabalho" id="{599d5791-adfe-ac9a-2f69-d8e718107a4e}">
           <p14:sldIdLst>
             <p14:sldId id="256"/>
             <p14:sldId id="257"/>
@@ -157,7 +157,7 @@
             <p14:sldId id="273"/>
           </p14:sldIdLst>
         </p14:section>
-        <p14:section name="Tutorial das tecnologias" id="{6eb22da7-6af1-b66b-67b1-61cc6ee2e24a}">
+        <p14:section name="Tutorial das tecnologias" id="{cd24d311-024d-9314-acc1-0c55df1d024b}">
           <p14:sldIdLst>
             <p14:sldId id="274"/>
             <p14:sldId id="275"/>
@@ -8040,7 +8040,7 @@
                   <a:schemeClr val="tx1"/>
                 </a:solidFill>
               </a:rPr>
-              <a:t>É um comando (python -m creditar_semestre), ainda sem agendamento automático.</a:t>
+              <a:t>É um comando (python -m app.tarefas.creditar_semestre), ainda sem agendamento automático.</a:t>
             </a:r>
             <a:endParaRPr lang="en-US" sz="1600" dirty="0"/>
           </a:p>
@@ -10900,7 +10900,7 @@
                 <a:ea typeface="Courier New" pitchFamily="34" charset="-122"/>
                 <a:cs typeface="Courier New" pitchFamily="34" charset="-120"/>
               </a:rPr>
-              <a:t>      &amp;&amp; python -m seed</a:t>
+              <a:t>      &amp;&amp; python -m app.tarefas.seed</a:t>
             </a:r>
             <a:endParaRPr lang="en-US" sz="1300" dirty="0"/>
           </a:p>
@@ -10917,7 +10917,7 @@
                 <a:ea typeface="Courier New" pitchFamily="34" charset="-122"/>
                 <a:cs typeface="Courier New" pitchFamily="34" charset="-120"/>
               </a:rPr>
-              <a:t>      &amp;&amp; uvicorn main:app --port 8000"</a:t>
+              <a:t>      &amp;&amp; uvicorn app.main:app --port 8000"</a:t>
             </a:r>
             <a:endParaRPr lang="en-US" sz="1300" dirty="0"/>
           </a:p>
@@ -12379,7 +12379,7 @@
                   <a:schemeClr val="accent6"/>
                 </a:solidFill>
               </a:rPr>
-              <a:t>src/back/model/conta.py (trecho resumido e reformatado)</a:t>
+              <a:t>src/back/app/model/conta.py (trecho resumido e reformatado)</a:t>
             </a:r>
             <a:endParaRPr lang="en-US" sz="1100" dirty="0"/>
           </a:p>
@@ -13049,7 +13049,7 @@
                   <a:schemeClr val="accent6"/>
                 </a:solidFill>
               </a:rPr>
-              <a:t>src/back/controller/moedas_controller.py (trecho resumido e reformatado)</a:t>
+              <a:t>src/back/app/controller/rotas/moedas.py (trecho resumido e reformatado)</a:t>
             </a:r>
             <a:endParaRPr lang="en-US" sz="1100" dirty="0"/>
           </a:p>
@@ -13759,7 +13759,7 @@
                   <a:schemeClr val="accent6"/>
                 </a:solidFill>
               </a:rPr>
-              <a:t>src/back/service/servico_autenticacao.py (trecho resumido e reformatado)</a:t>
+              <a:t>src/back/app/service/servico_autenticacao.py (trecho resumido e reformatado)</a:t>
             </a:r>
             <a:endParaRPr lang="en-US" sz="1100" dirty="0"/>
           </a:p>
@@ -14429,7 +14429,7 @@
                   <a:schemeClr val="accent6"/>
                 </a:solidFill>
               </a:rPr>
-              <a:t>src/front/src/componentes/RotaProtegida.tsx (trecho resumido e reformatado)</a:t>
+              <a:t>src/front/src/componentes/acesso/RotaProtegida.tsx (trecho resumido e reformatado)</a:t>
             </a:r>
             <a:endParaRPr lang="en-US" sz="1100" dirty="0"/>
           </a:p>
@@ -19948,7 +19948,7 @@
                   <a:schemeClr val="accent6"/>
                 </a:solidFill>
               </a:rPr>
-              <a:t>src/back/repository (trecho resumido e reformatado)</a:t>
+              <a:t>src/back/app/repository (trecho resumido e reformatado)</a:t>
             </a:r>
             <a:endParaRPr lang="en-US" sz="1100" dirty="0"/>
           </a:p>

</xml_diff>

<commit_message>
docs: atualiza as notas dos slides com o envio real de e-mail testado
</commit_message>
<xml_diff>
--- a/docs/apresentacao/Lab03S03-Apresentacao.pptx
+++ b/docs/apresentacao/Lab03S03-Apresentacao.pptx
@@ -121,7 +121,7 @@
   <p:extLst>
     <p:ext uri="{521415D9-36F7-43E2-AB2F-B90AF26B5E84}">
       <p14:sectionLst xmlns:p14="http://schemas.microsoft.com/office/powerpoint/2010/main">
-        <p14:section name="O trabalho" id="{f151c33d-9b6f-d4e3-d97b-2c448b5e0bba}">
+        <p14:section name="O trabalho" id="{3fbd5702-358c-880e-b7bf-5f896aec71fa}">
           <p14:sldIdLst>
             <p14:sldId id="256"/>
             <p14:sldId id="257"/>
@@ -131,7 +131,7 @@
             <p14:sldId id="261"/>
           </p14:sldIdLst>
         </p14:section>
-        <p14:section name="Oficina" id="{df22f3b3-0236-d9eb-0fd5-727beb7dcc73}">
+        <p14:section name="Oficina" id="{dcf36a21-c242-f4da-8319-2a4c7ef0a022}">
           <p14:sldIdLst>
             <p14:sldId id="262"/>
             <p14:sldId id="263"/>
@@ -1528,7 +1528,7 @@
             <a:r>
               <a:rPr lang="en-US" dirty="0"/>
               <a:t>O extrato do aluno mostra o saldo e cada movimentação: o que entrou, em verde, e o que saiu, em vermelho. No resgate saem dois e-mails. O primeiro vai para o aluno, com o cupom. O segundo vai para a empresa, avisando que aquele aluno resgatou a vantagem. O código é o mesmo nos dois de propósito: o aluno apresenta o cupom na empresa e ela confere se bate com o código que recebeu. O envio usa o SMTP do Gmail configurado no arquivo .env; sem credenciais, o texto aparece no log da API e nada é enviado.
-[Tempo: 0:35 | Dica: Se perguntarem por que o código se repete: é a forma de a empresa conferir o cupom do aluno. Seja transparente: o envio real pelo Gmail depende da senha de aplicativo; nos testes foi usado um SMTP simulado.]</a:t>
+[Tempo: 0:35 | Dica: Se perguntarem por que o código se repete: é a forma de a empresa conferir o cupom do aluno. O envio real pelo Gmail foi testado e os e-mails chegaram; se o computador da apresentação não tiver o .env, o texto aparece só no log.]</a:t>
             </a:r>
             <a:endParaRPr lang="en-US" dirty="0"/>
           </a:p>

</xml_diff>

<commit_message>
docs: mostra no slide 6 o print dos e-mails recebidos no Gmail
</commit_message>
<xml_diff>
--- a/docs/apresentacao/Lab03S03-Apresentacao.pptx
+++ b/docs/apresentacao/Lab03S03-Apresentacao.pptx
@@ -121,7 +121,7 @@
   <p:extLst>
     <p:ext uri="{521415D9-36F7-43E2-AB2F-B90AF26B5E84}">
       <p14:sectionLst xmlns:p14="http://schemas.microsoft.com/office/powerpoint/2010/main">
-        <p14:section name="O trabalho" id="{3fbd5702-358c-880e-b7bf-5f896aec71fa}">
+        <p14:section name="O trabalho" id="{e16d8be7-bba4-0436-f4c8-8f2e9b5cc70f}">
           <p14:sldIdLst>
             <p14:sldId id="256"/>
             <p14:sldId id="257"/>
@@ -131,7 +131,7 @@
             <p14:sldId id="261"/>
           </p14:sldIdLst>
         </p14:section>
-        <p14:section name="Oficina" id="{dcf36a21-c242-f4da-8319-2a4c7ef0a022}">
+        <p14:section name="Oficina" id="{b7b67ae8-13de-f094-69b0-ce76f8582603}">
           <p14:sldIdLst>
             <p14:sldId id="262"/>
             <p14:sldId id="263"/>
@@ -1527,8 +1527,8 @@
           <a:p>
             <a:r>
               <a:rPr lang="en-US" dirty="0"/>
-              <a:t>O extrato do aluno mostra o saldo e cada movimentação: o que entrou, em verde, e o que saiu, em vermelho. No resgate saem dois e-mails. O primeiro vai para o aluno, com o cupom. O segundo vai para a empresa, avisando que aquele aluno resgatou a vantagem. O código é o mesmo nos dois de propósito: o aluno apresenta o cupom na empresa e ela confere se bate com o código que recebeu. O envio usa o SMTP do Gmail configurado no arquivo .env; sem credenciais, o texto aparece no log da API e nada é enviado.
-[Tempo: 0:35 | Dica: Se perguntarem por que o código se repete: é a forma de a empresa conferir o cupom do aluno. O envio real pelo Gmail foi testado e os e-mails chegaram; se o computador da apresentação não tiver o .env, o texto aparece só no log.]</a:t>
+              <a:t>O extrato do aluno mostra o saldo e cada movimentação: o que entrou, em verde, e o que saiu, em vermelho. No resgate saem dois e-mails. O primeiro vai para o aluno, com o cupom. O segundo vai para a empresa, avisando que aquele aluno resgatou a vantagem. O código é o mesmo nos dois de propósito: o aluno apresenta o cupom na empresa e ela confere se bate com o código que recebeu. À direita, o print dos e-mails que chegaram de verdade na minha caixa do Gmail durante o teste, incluindo o aviso de moedas recebidas. O envio usa o SMTP do Gmail configurado no arquivo .env; sem credenciais, o texto aparece no log da API e nada é enviado.
+[Tempo: 0:35 | Dica: Aponte para o print à direita: são e-mails reais, recebidos no celular. Se perguntarem por que o código se repete: é a forma de a empresa conferir o cupom do aluno. Se o computador da apresentação não tiver o .env, o texto aparece só no log.]</a:t>
             </a:r>
             <a:endParaRPr lang="en-US" dirty="0"/>
           </a:p>
@@ -2796,7 +2796,7 @@
       </p:sp>
       <p:sp>
         <p:nvSpPr>
-          <p:cNvPr id="3" name="etiqueta-116"/>
+          <p:cNvPr id="3" name="etiqueta-105"/>
           <p:cNvSpPr/>
           <p:nvPr/>
         </p:nvSpPr>
@@ -2818,7 +2818,7 @@
       </p:sp>
       <p:sp>
         <p:nvSpPr>
-          <p:cNvPr id="4" name="texto-117"/>
+          <p:cNvPr id="4" name="texto-106"/>
           <p:cNvSpPr txBox="1"/>
           <p:nvPr/>
         </p:nvSpPr>
@@ -2854,7 +2854,7 @@
       </p:sp>
       <p:sp>
         <p:nvSpPr>
-          <p:cNvPr id="5" name="texto-118"/>
+          <p:cNvPr id="5" name="texto-107"/>
           <p:cNvSpPr txBox="1"/>
           <p:nvPr/>
         </p:nvSpPr>
@@ -2890,7 +2890,7 @@
       </p:sp>
       <p:sp>
         <p:nvSpPr>
-          <p:cNvPr id="6" name="texto-119"/>
+          <p:cNvPr id="6" name="texto-108"/>
           <p:cNvSpPr txBox="1"/>
           <p:nvPr/>
         </p:nvSpPr>
@@ -2926,7 +2926,7 @@
       </p:sp>
       <p:sp>
         <p:nvSpPr>
-          <p:cNvPr id="7" name="texto-120"/>
+          <p:cNvPr id="7" name="texto-109"/>
           <p:cNvSpPr txBox="1"/>
           <p:nvPr/>
         </p:nvSpPr>
@@ -2962,7 +2962,7 @@
       </p:sp>
       <p:sp>
         <p:nvSpPr>
-          <p:cNvPr id="8" name="texto-121"/>
+          <p:cNvPr id="8" name="texto-110"/>
           <p:cNvSpPr txBox="1"/>
           <p:nvPr/>
         </p:nvSpPr>
@@ -3060,7 +3060,7 @@
       </p:sp>
       <p:sp>
         <p:nvSpPr>
-          <p:cNvPr id="9" name="painel-codigo-122"/>
+          <p:cNvPr id="9" name="painel-codigo-111"/>
           <p:cNvSpPr/>
           <p:nvPr/>
         </p:nvSpPr>
@@ -3082,7 +3082,7 @@
       </p:sp>
       <p:sp>
         <p:nvSpPr>
-          <p:cNvPr id="10" name="texto-123"/>
+          <p:cNvPr id="10" name="texto-112"/>
           <p:cNvSpPr txBox="1"/>
           <p:nvPr/>
         </p:nvSpPr>
@@ -3121,7 +3121,7 @@
       </p:sp>
       <p:sp>
         <p:nvSpPr>
-          <p:cNvPr id="11" name="texto-124"/>
+          <p:cNvPr id="11" name="texto-113"/>
           <p:cNvSpPr txBox="1"/>
           <p:nvPr/>
         </p:nvSpPr>
@@ -3314,7 +3314,7 @@
       </p:sp>
       <p:sp>
         <p:nvSpPr>
-          <p:cNvPr id="12" name="painel-codigo-125"/>
+          <p:cNvPr id="12" name="painel-codigo-114"/>
           <p:cNvSpPr/>
           <p:nvPr/>
         </p:nvSpPr>
@@ -3336,7 +3336,7 @@
       </p:sp>
       <p:sp>
         <p:nvSpPr>
-          <p:cNvPr id="13" name="texto-126"/>
+          <p:cNvPr id="13" name="texto-115"/>
           <p:cNvSpPr txBox="1"/>
           <p:nvPr/>
         </p:nvSpPr>
@@ -3375,7 +3375,7 @@
       </p:sp>
       <p:sp>
         <p:nvSpPr>
-          <p:cNvPr id="14" name="texto-127"/>
+          <p:cNvPr id="14" name="texto-116"/>
           <p:cNvSpPr txBox="1"/>
           <p:nvPr/>
         </p:nvSpPr>
@@ -3539,7 +3539,7 @@
       </p:sp>
       <p:sp>
         <p:nvSpPr>
-          <p:cNvPr id="3" name="etiqueta-128"/>
+          <p:cNvPr id="3" name="etiqueta-117"/>
           <p:cNvSpPr/>
           <p:nvPr/>
         </p:nvSpPr>
@@ -3561,7 +3561,7 @@
       </p:sp>
       <p:sp>
         <p:nvSpPr>
-          <p:cNvPr id="4" name="texto-129"/>
+          <p:cNvPr id="4" name="texto-118"/>
           <p:cNvSpPr txBox="1"/>
           <p:nvPr/>
         </p:nvSpPr>
@@ -3597,7 +3597,7 @@
       </p:sp>
       <p:sp>
         <p:nvSpPr>
-          <p:cNvPr id="5" name="texto-130"/>
+          <p:cNvPr id="5" name="texto-119"/>
           <p:cNvSpPr txBox="1"/>
           <p:nvPr/>
         </p:nvSpPr>
@@ -3633,7 +3633,7 @@
       </p:sp>
       <p:sp>
         <p:nvSpPr>
-          <p:cNvPr id="6" name="texto-131"/>
+          <p:cNvPr id="6" name="texto-120"/>
           <p:cNvSpPr txBox="1"/>
           <p:nvPr/>
         </p:nvSpPr>
@@ -3669,7 +3669,7 @@
       </p:sp>
       <p:sp>
         <p:nvSpPr>
-          <p:cNvPr id="7" name="texto-132"/>
+          <p:cNvPr id="7" name="texto-121"/>
           <p:cNvSpPr txBox="1"/>
           <p:nvPr/>
         </p:nvSpPr>
@@ -3705,7 +3705,7 @@
       </p:sp>
       <p:sp>
         <p:nvSpPr>
-          <p:cNvPr id="8" name="texto-133"/>
+          <p:cNvPr id="8" name="texto-122"/>
           <p:cNvSpPr txBox="1"/>
           <p:nvPr/>
         </p:nvSpPr>
@@ -3803,7 +3803,7 @@
       </p:sp>
       <p:sp>
         <p:nvSpPr>
-          <p:cNvPr id="9" name="painel-codigo-134"/>
+          <p:cNvPr id="9" name="painel-codigo-123"/>
           <p:cNvSpPr/>
           <p:nvPr/>
         </p:nvSpPr>
@@ -3825,7 +3825,7 @@
       </p:sp>
       <p:sp>
         <p:nvSpPr>
-          <p:cNvPr id="10" name="texto-135"/>
+          <p:cNvPr id="10" name="texto-124"/>
           <p:cNvSpPr txBox="1"/>
           <p:nvPr/>
         </p:nvSpPr>
@@ -3864,7 +3864,7 @@
       </p:sp>
       <p:sp>
         <p:nvSpPr>
-          <p:cNvPr id="11" name="texto-136"/>
+          <p:cNvPr id="11" name="texto-125"/>
           <p:cNvSpPr txBox="1"/>
           <p:nvPr/>
         </p:nvSpPr>
@@ -4199,7 +4199,7 @@
       </p:sp>
       <p:sp>
         <p:nvSpPr>
-          <p:cNvPr id="3" name="etiqueta-137"/>
+          <p:cNvPr id="3" name="etiqueta-126"/>
           <p:cNvSpPr/>
           <p:nvPr/>
         </p:nvSpPr>
@@ -4221,7 +4221,7 @@
       </p:sp>
       <p:sp>
         <p:nvSpPr>
-          <p:cNvPr id="4" name="texto-138"/>
+          <p:cNvPr id="4" name="texto-127"/>
           <p:cNvSpPr txBox="1"/>
           <p:nvPr/>
         </p:nvSpPr>
@@ -4257,7 +4257,7 @@
       </p:sp>
       <p:sp>
         <p:nvSpPr>
-          <p:cNvPr id="5" name="texto-139"/>
+          <p:cNvPr id="5" name="texto-128"/>
           <p:cNvSpPr txBox="1"/>
           <p:nvPr/>
         </p:nvSpPr>
@@ -4293,7 +4293,7 @@
       </p:sp>
       <p:sp>
         <p:nvSpPr>
-          <p:cNvPr id="6" name="texto-140"/>
+          <p:cNvPr id="6" name="texto-129"/>
           <p:cNvSpPr txBox="1"/>
           <p:nvPr/>
         </p:nvSpPr>
@@ -4329,7 +4329,7 @@
       </p:sp>
       <p:sp>
         <p:nvSpPr>
-          <p:cNvPr id="7" name="texto-141"/>
+          <p:cNvPr id="7" name="texto-130"/>
           <p:cNvSpPr txBox="1"/>
           <p:nvPr/>
         </p:nvSpPr>
@@ -4365,7 +4365,7 @@
       </p:sp>
       <p:sp>
         <p:nvSpPr>
-          <p:cNvPr id="8" name="texto-142"/>
+          <p:cNvPr id="8" name="texto-131"/>
           <p:cNvSpPr txBox="1"/>
           <p:nvPr/>
         </p:nvSpPr>
@@ -4463,7 +4463,7 @@
       </p:sp>
       <p:sp>
         <p:nvSpPr>
-          <p:cNvPr id="9" name="painel-codigo-143"/>
+          <p:cNvPr id="9" name="painel-codigo-132"/>
           <p:cNvSpPr/>
           <p:nvPr/>
         </p:nvSpPr>
@@ -4485,7 +4485,7 @@
       </p:sp>
       <p:sp>
         <p:nvSpPr>
-          <p:cNvPr id="10" name="texto-144"/>
+          <p:cNvPr id="10" name="texto-133"/>
           <p:cNvSpPr txBox="1"/>
           <p:nvPr/>
         </p:nvSpPr>
@@ -4524,7 +4524,7 @@
       </p:sp>
       <p:sp>
         <p:nvSpPr>
-          <p:cNvPr id="11" name="texto-145"/>
+          <p:cNvPr id="11" name="texto-134"/>
           <p:cNvSpPr txBox="1"/>
           <p:nvPr/>
         </p:nvSpPr>
@@ -4637,7 +4637,7 @@
       </p:sp>
       <p:sp>
         <p:nvSpPr>
-          <p:cNvPr id="12" name="painel-codigo-146"/>
+          <p:cNvPr id="12" name="painel-codigo-135"/>
           <p:cNvSpPr/>
           <p:nvPr/>
         </p:nvSpPr>
@@ -4659,7 +4659,7 @@
       </p:sp>
       <p:sp>
         <p:nvSpPr>
-          <p:cNvPr id="13" name="texto-147"/>
+          <p:cNvPr id="13" name="texto-136"/>
           <p:cNvSpPr txBox="1"/>
           <p:nvPr/>
         </p:nvSpPr>
@@ -4698,7 +4698,7 @@
       </p:sp>
       <p:sp>
         <p:nvSpPr>
-          <p:cNvPr id="14" name="texto-148"/>
+          <p:cNvPr id="14" name="texto-137"/>
           <p:cNvSpPr txBox="1"/>
           <p:nvPr/>
         </p:nvSpPr>
@@ -4970,7 +4970,7 @@
       </p:sp>
       <p:sp>
         <p:nvSpPr>
-          <p:cNvPr id="3" name="etiqueta-149"/>
+          <p:cNvPr id="3" name="etiqueta-138"/>
           <p:cNvSpPr/>
           <p:nvPr/>
         </p:nvSpPr>
@@ -4992,7 +4992,7 @@
       </p:sp>
       <p:sp>
         <p:nvSpPr>
-          <p:cNvPr id="4" name="texto-150"/>
+          <p:cNvPr id="4" name="texto-139"/>
           <p:cNvSpPr txBox="1"/>
           <p:nvPr/>
         </p:nvSpPr>
@@ -5028,7 +5028,7 @@
       </p:sp>
       <p:sp>
         <p:nvSpPr>
-          <p:cNvPr id="5" name="texto-151"/>
+          <p:cNvPr id="5" name="texto-140"/>
           <p:cNvSpPr txBox="1"/>
           <p:nvPr/>
         </p:nvSpPr>
@@ -5064,7 +5064,7 @@
       </p:sp>
       <p:sp>
         <p:nvSpPr>
-          <p:cNvPr id="6" name="texto-152"/>
+          <p:cNvPr id="6" name="texto-141"/>
           <p:cNvSpPr txBox="1"/>
           <p:nvPr/>
         </p:nvSpPr>
@@ -5100,7 +5100,7 @@
       </p:sp>
       <p:sp>
         <p:nvSpPr>
-          <p:cNvPr id="7" name="texto-153"/>
+          <p:cNvPr id="7" name="texto-142"/>
           <p:cNvSpPr txBox="1"/>
           <p:nvPr/>
         </p:nvSpPr>
@@ -5136,7 +5136,7 @@
       </p:sp>
       <p:sp>
         <p:nvSpPr>
-          <p:cNvPr id="8" name="texto-154"/>
+          <p:cNvPr id="8" name="texto-143"/>
           <p:cNvSpPr txBox="1"/>
           <p:nvPr/>
         </p:nvSpPr>
@@ -5234,7 +5234,7 @@
       </p:sp>
       <p:sp>
         <p:nvSpPr>
-          <p:cNvPr id="9" name="painel-codigo-155"/>
+          <p:cNvPr id="9" name="painel-codigo-144"/>
           <p:cNvSpPr/>
           <p:nvPr/>
         </p:nvSpPr>
@@ -5256,7 +5256,7 @@
       </p:sp>
       <p:sp>
         <p:nvSpPr>
-          <p:cNvPr id="10" name="texto-156"/>
+          <p:cNvPr id="10" name="texto-145"/>
           <p:cNvSpPr txBox="1"/>
           <p:nvPr/>
         </p:nvSpPr>
@@ -5295,7 +5295,7 @@
       </p:sp>
       <p:sp>
         <p:nvSpPr>
-          <p:cNvPr id="11" name="texto-157"/>
+          <p:cNvPr id="11" name="texto-146"/>
           <p:cNvSpPr txBox="1"/>
           <p:nvPr/>
         </p:nvSpPr>
@@ -5459,7 +5459,7 @@
       </p:sp>
       <p:sp>
         <p:nvSpPr>
-          <p:cNvPr id="12" name="painel-codigo-158"/>
+          <p:cNvPr id="12" name="painel-codigo-147"/>
           <p:cNvSpPr/>
           <p:nvPr/>
         </p:nvSpPr>
@@ -5481,7 +5481,7 @@
       </p:sp>
       <p:sp>
         <p:nvSpPr>
-          <p:cNvPr id="13" name="texto-159"/>
+          <p:cNvPr id="13" name="texto-148"/>
           <p:cNvSpPr txBox="1"/>
           <p:nvPr/>
         </p:nvSpPr>
@@ -5520,7 +5520,7 @@
       </p:sp>
       <p:sp>
         <p:nvSpPr>
-          <p:cNvPr id="14" name="texto-160"/>
+          <p:cNvPr id="14" name="texto-149"/>
           <p:cNvSpPr txBox="1"/>
           <p:nvPr/>
         </p:nvSpPr>
@@ -5718,7 +5718,7 @@
       </p:sp>
       <p:sp>
         <p:nvSpPr>
-          <p:cNvPr id="3" name="etiqueta-161"/>
+          <p:cNvPr id="3" name="etiqueta-150"/>
           <p:cNvSpPr/>
           <p:nvPr/>
         </p:nvSpPr>
@@ -5740,7 +5740,7 @@
       </p:sp>
       <p:sp>
         <p:nvSpPr>
-          <p:cNvPr id="4" name="texto-162"/>
+          <p:cNvPr id="4" name="texto-151"/>
           <p:cNvSpPr txBox="1"/>
           <p:nvPr/>
         </p:nvSpPr>
@@ -5776,7 +5776,7 @@
       </p:sp>
       <p:sp>
         <p:nvSpPr>
-          <p:cNvPr id="5" name="texto-163"/>
+          <p:cNvPr id="5" name="texto-152"/>
           <p:cNvSpPr txBox="1"/>
           <p:nvPr/>
         </p:nvSpPr>
@@ -5812,7 +5812,7 @@
       </p:sp>
       <p:sp>
         <p:nvSpPr>
-          <p:cNvPr id="6" name="texto-164"/>
+          <p:cNvPr id="6" name="texto-153"/>
           <p:cNvSpPr txBox="1"/>
           <p:nvPr/>
         </p:nvSpPr>
@@ -5848,7 +5848,7 @@
       </p:sp>
       <p:sp>
         <p:nvSpPr>
-          <p:cNvPr id="7" name="texto-165"/>
+          <p:cNvPr id="7" name="texto-154"/>
           <p:cNvSpPr txBox="1"/>
           <p:nvPr/>
         </p:nvSpPr>
@@ -5884,7 +5884,7 @@
       </p:sp>
       <p:sp>
         <p:nvSpPr>
-          <p:cNvPr id="8" name="texto-166"/>
+          <p:cNvPr id="8" name="texto-155"/>
           <p:cNvSpPr txBox="1"/>
           <p:nvPr/>
         </p:nvSpPr>
@@ -5982,7 +5982,7 @@
       </p:sp>
       <p:sp>
         <p:nvSpPr>
-          <p:cNvPr id="9" name="painel-codigo-167"/>
+          <p:cNvPr id="9" name="painel-codigo-156"/>
           <p:cNvSpPr/>
           <p:nvPr/>
         </p:nvSpPr>
@@ -6004,7 +6004,7 @@
       </p:sp>
       <p:sp>
         <p:nvSpPr>
-          <p:cNvPr id="10" name="texto-168"/>
+          <p:cNvPr id="10" name="texto-157"/>
           <p:cNvSpPr txBox="1"/>
           <p:nvPr/>
         </p:nvSpPr>
@@ -6043,7 +6043,7 @@
       </p:sp>
       <p:sp>
         <p:nvSpPr>
-          <p:cNvPr id="11" name="texto-169"/>
+          <p:cNvPr id="11" name="texto-158"/>
           <p:cNvSpPr txBox="1"/>
           <p:nvPr/>
         </p:nvSpPr>
@@ -6133,7 +6133,7 @@
       </p:sp>
       <p:sp>
         <p:nvSpPr>
-          <p:cNvPr id="12" name="painel-codigo-170"/>
+          <p:cNvPr id="12" name="painel-codigo-159"/>
           <p:cNvSpPr/>
           <p:nvPr/>
         </p:nvSpPr>
@@ -6155,7 +6155,7 @@
       </p:sp>
       <p:sp>
         <p:nvSpPr>
-          <p:cNvPr id="13" name="texto-171"/>
+          <p:cNvPr id="13" name="texto-160"/>
           <p:cNvSpPr txBox="1"/>
           <p:nvPr/>
         </p:nvSpPr>
@@ -6194,7 +6194,7 @@
       </p:sp>
       <p:sp>
         <p:nvSpPr>
-          <p:cNvPr id="14" name="texto-172"/>
+          <p:cNvPr id="14" name="texto-161"/>
           <p:cNvSpPr txBox="1"/>
           <p:nvPr/>
         </p:nvSpPr>
@@ -8502,7 +8502,7 @@
         <p:spPr>
           <a:xfrm>
             <a:off x="548640" y="1325880"/>
-            <a:ext cx="5760720" cy="2241280"/>
+            <a:ext cx="6035040" cy="2348008"/>
           </a:xfrm>
           <a:prstGeom prst="rect">
             <a:avLst/>
@@ -8524,8 +8524,8 @@
         </p:nvSpPr>
         <p:spPr>
           <a:xfrm>
-            <a:off x="548640" y="3704320"/>
-            <a:ext cx="5760720" cy="365760"/>
+            <a:off x="548640" y="3811048"/>
+            <a:ext cx="6035040" cy="365760"/>
           </a:xfrm>
           <a:prstGeom prst="rect">
             <a:avLst/>
@@ -8554,29 +8554,84 @@
       </p:sp>
       <p:sp>
         <p:nvSpPr>
-          <p:cNvPr id="5" name="email-53"/>
-          <p:cNvSpPr/>
-          <p:nvPr/>
-        </p:nvSpPr>
-        <p:spPr>
-          <a:xfrm>
-            <a:off x="6675120" y="1325880"/>
-            <a:ext cx="4965192" cy="1828800"/>
-          </a:xfrm>
-          <a:prstGeom prst="roundRect">
-            <a:avLst>
-              <a:gd name="adj" fmla="val 4000"/>
-            </a:avLst>
-          </a:prstGeom>
-          <a:solidFill>
-            <a:schemeClr val="bg1"/>
-          </a:solidFill>
-          <a:ln w="12700">
-            <a:solidFill>
-              <a:schemeClr val="accent6"/>
-            </a:solidFill>
-            <a:prstDash val="solid"/>
-          </a:ln>
+          <p:cNvPr id="5" name="texto-53"/>
+          <p:cNvSpPr txBox="1"/>
+          <p:nvPr/>
+        </p:nvSpPr>
+        <p:spPr>
+          <a:xfrm>
+            <a:off x="548640" y="4663440"/>
+            <a:ext cx="6035040" cy="1554480"/>
+          </a:xfrm>
+          <a:prstGeom prst="rect">
+            <a:avLst/>
+          </a:prstGeom>
+          <a:noFill/>
+          <a:ln/>
+        </p:spPr>
+        <p:txBody>
+          <a:bodyPr wrap="square" lIns="0" tIns="0" rIns="0" bIns="0" rtlCol="0" anchor="t"/>
+          <a:lstStyle/>
+          <a:p>
+            <a:pPr marL="342900" indent="-342900">
+              <a:spcAft>
+                <a:spcPts val="800"/>
+              </a:spcAft>
+              <a:buSzPct val="100000"/>
+              <a:buChar char="•"/>
+            </a:pPr>
+            <a:r>
+              <a:rPr lang="en-US" sz="1700" dirty="0">
+                <a:solidFill>
+                  <a:schemeClr val="tx1"/>
+                </a:solidFill>
+              </a:rPr>
+              <a:t>No resgate saem dois e-mails: o cupom para o aluno e o aviso para a empresa.</a:t>
+            </a:r>
+            <a:endParaRPr lang="en-US" sz="1700" dirty="0"/>
+          </a:p>
+          <a:p>
+            <a:pPr marL="342900" indent="-342900">
+              <a:spcAft>
+                <a:spcPts val="800"/>
+              </a:spcAft>
+              <a:buSzPct val="100000"/>
+              <a:buChar char="•"/>
+            </a:pPr>
+            <a:r>
+              <a:rPr lang="en-US" sz="1700" dirty="0">
+                <a:solidFill>
+                  <a:schemeClr val="tx1"/>
+                </a:solidFill>
+              </a:rPr>
+              <a:t>O código é o mesmo nos dois de propósito: o aluno apresenta o cupom e a empresa confere com o código que recebeu.</a:t>
+            </a:r>
+            <a:endParaRPr lang="en-US" sz="1700" dirty="0"/>
+          </a:p>
+        </p:txBody>
+      </p:sp>
+      <p:pic>
+        <p:nvPicPr>
+          <p:cNvPr id="6" name="imagem-54" descr="Os três e-mails recebidos na caixa do Gmail">    </p:cNvPr>
+          <p:cNvPicPr>
+            <a:picLocks noChangeAspect="1"/>
+          </p:cNvPicPr>
+          <p:nvPr/>
+        </p:nvPicPr>
+        <p:blipFill>
+          <a:blip r:embed="rId2"/>
+          <a:stretch>
+            <a:fillRect/>
+          </a:stretch>
+        </p:blipFill>
+        <p:spPr>
+          <a:xfrm>
+            <a:off x="7967073" y="1325880"/>
+            <a:ext cx="2564166" cy="4663440"/>
+          </a:xfrm>
+          <a:prstGeom prst="rect">
+            <a:avLst/>
+          </a:prstGeom>
           <a:effectLst>
             <a:outerShdw sx="100000" sy="100000" kx="0" ky="0" algn="bl" rotWithShape="0" blurRad="101600" dist="25400" dir="5400000">
               <a:srgbClr val="000000">
@@ -8585,43 +8640,7 @@
             </a:outerShdw>
           </a:effectLst>
         </p:spPr>
-      </p:sp>
-      <p:sp>
-        <p:nvSpPr>
-          <p:cNvPr id="6" name="texto-54"/>
-          <p:cNvSpPr txBox="1"/>
-          <p:nvPr/>
-        </p:nvSpPr>
-        <p:spPr>
-          <a:xfrm>
-            <a:off x="6903720" y="1417320"/>
-            <a:ext cx="4572000" cy="274320"/>
-          </a:xfrm>
-          <a:prstGeom prst="rect">
-            <a:avLst/>
-          </a:prstGeom>
-          <a:noFill/>
-          <a:ln/>
-        </p:spPr>
-        <p:txBody>
-          <a:bodyPr wrap="square" lIns="0" tIns="0" rIns="0" bIns="0" rtlCol="0" anchor="ctr"/>
-          <a:lstStyle/>
-          <a:p>
-            <a:pPr indent="0" marL="0">
-              <a:buNone/>
-            </a:pPr>
-            <a:r>
-              <a:rPr lang="en-US" sz="1200" b="1" dirty="0">
-                <a:solidFill>
-                  <a:schemeClr val="accent1"/>
-                </a:solidFill>
-              </a:rPr>
-              <a:t>E-mail para o aluno</a:t>
-            </a:r>
-            <a:endParaRPr lang="en-US" sz="1200" dirty="0"/>
-          </a:p>
-        </p:txBody>
-      </p:sp>
+      </p:pic>
       <p:sp>
         <p:nvSpPr>
           <p:cNvPr id="7" name="texto-55"/>
@@ -8630,8 +8649,8 @@
         </p:nvSpPr>
         <p:spPr>
           <a:xfrm>
-            <a:off x="6903720" y="1709928"/>
-            <a:ext cx="4572000" cy="256032"/>
+            <a:off x="6858000" y="6126480"/>
+            <a:ext cx="4782312" cy="365760"/>
           </a:xfrm>
           <a:prstGeom prst="rect">
             <a:avLst/>
@@ -8643,394 +8662,18 @@
           <a:bodyPr wrap="square" lIns="0" tIns="0" rIns="0" bIns="0" rtlCol="0" anchor="ctr"/>
           <a:lstStyle/>
           <a:p>
-            <a:pPr indent="0" marL="0">
-              <a:buNone/>
-            </a:pPr>
-            <a:r>
-              <a:rPr lang="en-US" sz="1200" dirty="0">
+            <a:pPr algn="ctr" indent="0" marL="0">
+              <a:buNone/>
+            </a:pPr>
+            <a:r>
+              <a:rPr lang="en-US" sz="1400" dirty="0">
                 <a:solidFill>
                   <a:schemeClr val="accent6"/>
                 </a:solidFill>
               </a:rPr>
-              <a:t>Para: mariana@aluno.com.br</a:t>
-            </a:r>
-            <a:endParaRPr lang="en-US" sz="1200" dirty="0"/>
-          </a:p>
-        </p:txBody>
-      </p:sp>
-      <p:sp>
-        <p:nvSpPr>
-          <p:cNvPr id="8" name="texto-56"/>
-          <p:cNvSpPr txBox="1"/>
-          <p:nvPr/>
-        </p:nvSpPr>
-        <p:spPr>
-          <a:xfrm>
-            <a:off x="6903720" y="1965960"/>
-            <a:ext cx="4572000" cy="274320"/>
-          </a:xfrm>
-          <a:prstGeom prst="rect">
-            <a:avLst/>
-          </a:prstGeom>
-          <a:noFill/>
-          <a:ln/>
-        </p:spPr>
-        <p:txBody>
-          <a:bodyPr wrap="square" lIns="0" tIns="0" rIns="0" bIns="0" rtlCol="0" anchor="ctr"/>
-          <a:lstStyle/>
-          <a:p>
-            <a:pPr indent="0" marL="0">
-              <a:buNone/>
-            </a:pPr>
-            <a:r>
-              <a:rPr lang="en-US" sz="1300" b="1" dirty="0">
-                <a:solidFill>
-                  <a:schemeClr val="tx1"/>
-                </a:solidFill>
-              </a:rPr>
-              <a:t>Assunto: Seu cupom de resgate</a:t>
-            </a:r>
-            <a:endParaRPr lang="en-US" sz="1300" dirty="0"/>
-          </a:p>
-        </p:txBody>
-      </p:sp>
-      <p:sp>
-        <p:nvSpPr>
-          <p:cNvPr id="9" name="linha-57"/>
-          <p:cNvSpPr/>
-          <p:nvPr/>
-        </p:nvSpPr>
-        <p:spPr>
-          <a:xfrm>
-            <a:off x="6903720" y="2286000"/>
-            <a:ext cx="4507992" cy="0"/>
-          </a:xfrm>
-          <a:prstGeom prst="line">
-            <a:avLst/>
-          </a:prstGeom>
-          <a:noFill/>
-          <a:ln w="9525">
-            <a:solidFill>
-              <a:schemeClr val="accent6"/>
-            </a:solidFill>
-            <a:prstDash val="solid"/>
-          </a:ln>
-        </p:spPr>
-      </p:sp>
-      <p:sp>
-        <p:nvSpPr>
-          <p:cNvPr id="10" name="texto-58"/>
-          <p:cNvSpPr txBox="1"/>
-          <p:nvPr/>
-        </p:nvSpPr>
-        <p:spPr>
-          <a:xfrm>
-            <a:off x="6903720" y="2350008"/>
-            <a:ext cx="4507992" cy="731520"/>
-          </a:xfrm>
-          <a:prstGeom prst="rect">
-            <a:avLst/>
-          </a:prstGeom>
-          <a:noFill/>
-          <a:ln/>
-        </p:spPr>
-        <p:txBody>
-          <a:bodyPr wrap="square" lIns="0" tIns="0" rIns="0" bIns="0" rtlCol="0" anchor="t"/>
-          <a:lstStyle/>
-          <a:p>
-            <a:pPr indent="0" marL="0">
-              <a:buNone/>
-            </a:pPr>
-            <a:r>
-              <a:rPr lang="en-US" sz="1250" dirty="0">
-                <a:solidFill>
-                  <a:schemeClr val="tx1"/>
-                </a:solidFill>
-              </a:rPr>
-              <a:t>Você trocou 60 moedas pela vantagem "Almoço no restaurante universitário". </a:t>
-            </a:r>
-            <a:pPr indent="0" marL="0">
-              <a:buNone/>
-            </a:pPr>
-            <a:r>
-              <a:rPr lang="en-US" sz="1250" b="1" dirty="0">
-                <a:solidFill>
-                  <a:schemeClr val="tx1"/>
-                </a:solidFill>
-              </a:rPr>
-              <a:t>Código do cupom: 3823V2QQ</a:t>
-            </a:r>
-            <a:endParaRPr lang="en-US" sz="1250" dirty="0"/>
-          </a:p>
-        </p:txBody>
-      </p:sp>
-      <p:sp>
-        <p:nvSpPr>
-          <p:cNvPr id="11" name="email-59"/>
-          <p:cNvSpPr/>
-          <p:nvPr/>
-        </p:nvSpPr>
-        <p:spPr>
-          <a:xfrm>
-            <a:off x="6675120" y="3337560"/>
-            <a:ext cx="4965192" cy="1828800"/>
-          </a:xfrm>
-          <a:prstGeom prst="roundRect">
-            <a:avLst>
-              <a:gd name="adj" fmla="val 4000"/>
-            </a:avLst>
-          </a:prstGeom>
-          <a:solidFill>
-            <a:schemeClr val="bg1"/>
-          </a:solidFill>
-          <a:ln w="12700">
-            <a:solidFill>
-              <a:schemeClr val="accent6"/>
-            </a:solidFill>
-            <a:prstDash val="solid"/>
-          </a:ln>
-          <a:effectLst>
-            <a:outerShdw sx="100000" sy="100000" kx="0" ky="0" algn="bl" rotWithShape="0" blurRad="101600" dist="25400" dir="5400000">
-              <a:srgbClr val="000000">
-                <a:alpha val="18000"/>
-              </a:srgbClr>
-            </a:outerShdw>
-          </a:effectLst>
-        </p:spPr>
-      </p:sp>
-      <p:sp>
-        <p:nvSpPr>
-          <p:cNvPr id="12" name="texto-60"/>
-          <p:cNvSpPr txBox="1"/>
-          <p:nvPr/>
-        </p:nvSpPr>
-        <p:spPr>
-          <a:xfrm>
-            <a:off x="6903720" y="3429000"/>
-            <a:ext cx="4572000" cy="274320"/>
-          </a:xfrm>
-          <a:prstGeom prst="rect">
-            <a:avLst/>
-          </a:prstGeom>
-          <a:noFill/>
-          <a:ln/>
-        </p:spPr>
-        <p:txBody>
-          <a:bodyPr wrap="square" lIns="0" tIns="0" rIns="0" bIns="0" rtlCol="0" anchor="ctr"/>
-          <a:lstStyle/>
-          <a:p>
-            <a:pPr indent="0" marL="0">
-              <a:buNone/>
-            </a:pPr>
-            <a:r>
-              <a:rPr lang="en-US" sz="1200" b="1" dirty="0">
-                <a:solidFill>
-                  <a:schemeClr val="accent1"/>
-                </a:solidFill>
-              </a:rPr>
-              <a:t>E-mail para a empresa</a:t>
-            </a:r>
-            <a:endParaRPr lang="en-US" sz="1200" dirty="0"/>
-          </a:p>
-        </p:txBody>
-      </p:sp>
-      <p:sp>
-        <p:nvSpPr>
-          <p:cNvPr id="13" name="texto-61"/>
-          <p:cNvSpPr txBox="1"/>
-          <p:nvPr/>
-        </p:nvSpPr>
-        <p:spPr>
-          <a:xfrm>
-            <a:off x="6903720" y="3721608"/>
-            <a:ext cx="4572000" cy="256032"/>
-          </a:xfrm>
-          <a:prstGeom prst="rect">
-            <a:avLst/>
-          </a:prstGeom>
-          <a:noFill/>
-          <a:ln/>
-        </p:spPr>
-        <p:txBody>
-          <a:bodyPr wrap="square" lIns="0" tIns="0" rIns="0" bIns="0" rtlCol="0" anchor="ctr"/>
-          <a:lstStyle/>
-          <a:p>
-            <a:pPr indent="0" marL="0">
-              <a:buNone/>
-            </a:pPr>
-            <a:r>
-              <a:rPr lang="en-US" sz="1200" dirty="0">
-                <a:solidFill>
-                  <a:schemeClr val="accent6"/>
-                </a:solidFill>
-              </a:rPr>
-              <a:t>Para: contato@cantina.com.br</a:t>
-            </a:r>
-            <a:endParaRPr lang="en-US" sz="1200" dirty="0"/>
-          </a:p>
-        </p:txBody>
-      </p:sp>
-      <p:sp>
-        <p:nvSpPr>
-          <p:cNvPr id="14" name="texto-62"/>
-          <p:cNvSpPr txBox="1"/>
-          <p:nvPr/>
-        </p:nvSpPr>
-        <p:spPr>
-          <a:xfrm>
-            <a:off x="6903720" y="3977640"/>
-            <a:ext cx="4572000" cy="274320"/>
-          </a:xfrm>
-          <a:prstGeom prst="rect">
-            <a:avLst/>
-          </a:prstGeom>
-          <a:noFill/>
-          <a:ln/>
-        </p:spPr>
-        <p:txBody>
-          <a:bodyPr wrap="square" lIns="0" tIns="0" rIns="0" bIns="0" rtlCol="0" anchor="ctr"/>
-          <a:lstStyle/>
-          <a:p>
-            <a:pPr indent="0" marL="0">
-              <a:buNone/>
-            </a:pPr>
-            <a:r>
-              <a:rPr lang="en-US" sz="1300" b="1" dirty="0">
-                <a:solidFill>
-                  <a:schemeClr val="tx1"/>
-                </a:solidFill>
-              </a:rPr>
-              <a:t>Assunto: Um aluno resgatou uma vantagem</a:t>
-            </a:r>
-            <a:endParaRPr lang="en-US" sz="1300" dirty="0"/>
-          </a:p>
-        </p:txBody>
-      </p:sp>
-      <p:sp>
-        <p:nvSpPr>
-          <p:cNvPr id="15" name="linha-63"/>
-          <p:cNvSpPr/>
-          <p:nvPr/>
-        </p:nvSpPr>
-        <p:spPr>
-          <a:xfrm>
-            <a:off x="6903720" y="4297680"/>
-            <a:ext cx="4507992" cy="0"/>
-          </a:xfrm>
-          <a:prstGeom prst="line">
-            <a:avLst/>
-          </a:prstGeom>
-          <a:noFill/>
-          <a:ln w="9525">
-            <a:solidFill>
-              <a:schemeClr val="accent6"/>
-            </a:solidFill>
-            <a:prstDash val="solid"/>
-          </a:ln>
-        </p:spPr>
-      </p:sp>
-      <p:sp>
-        <p:nvSpPr>
-          <p:cNvPr id="16" name="texto-64"/>
-          <p:cNvSpPr txBox="1"/>
-          <p:nvPr/>
-        </p:nvSpPr>
-        <p:spPr>
-          <a:xfrm>
-            <a:off x="6903720" y="4361688"/>
-            <a:ext cx="4507992" cy="731520"/>
-          </a:xfrm>
-          <a:prstGeom prst="rect">
-            <a:avLst/>
-          </a:prstGeom>
-          <a:noFill/>
-          <a:ln/>
-        </p:spPr>
-        <p:txBody>
-          <a:bodyPr wrap="square" lIns="0" tIns="0" rIns="0" bIns="0" rtlCol="0" anchor="t"/>
-          <a:lstStyle/>
-          <a:p>
-            <a:pPr indent="0" marL="0">
-              <a:buNone/>
-            </a:pPr>
-            <a:r>
-              <a:rPr lang="en-US" sz="1250" dirty="0">
-                <a:solidFill>
-                  <a:schemeClr val="tx1"/>
-                </a:solidFill>
-              </a:rPr>
-              <a:t>O aluno Mariana Alves Ribeiro resgatou a vantagem "Almoço no restaurante universitário". </a:t>
-            </a:r>
-            <a:pPr indent="0" marL="0">
-              <a:buNone/>
-            </a:pPr>
-            <a:r>
-              <a:rPr lang="en-US" sz="1250" b="1" dirty="0">
-                <a:solidFill>
-                  <a:schemeClr val="tx1"/>
-                </a:solidFill>
-              </a:rPr>
-              <a:t>Código para conferência: 3823V2QQ</a:t>
-            </a:r>
-            <a:endParaRPr lang="en-US" sz="1250" dirty="0"/>
-          </a:p>
-        </p:txBody>
-      </p:sp>
-      <p:sp>
-        <p:nvSpPr>
-          <p:cNvPr id="17" name="cartao-65"/>
-          <p:cNvSpPr/>
-          <p:nvPr/>
-        </p:nvSpPr>
-        <p:spPr>
-          <a:xfrm>
-            <a:off x="548640" y="5440680"/>
-            <a:ext cx="11091672" cy="822960"/>
-          </a:xfrm>
-          <a:prstGeom prst="roundRect">
-            <a:avLst>
-              <a:gd name="adj" fmla="val 13333"/>
-            </a:avLst>
-          </a:prstGeom>
-          <a:solidFill>
-            <a:schemeClr val="tx2"/>
-          </a:solidFill>
-          <a:ln/>
-        </p:spPr>
-      </p:sp>
-      <p:sp>
-        <p:nvSpPr>
-          <p:cNvPr id="18" name="texto-66"/>
-          <p:cNvSpPr txBox="1"/>
-          <p:nvPr/>
-        </p:nvSpPr>
-        <p:spPr>
-          <a:xfrm>
-            <a:off x="822960" y="5486400"/>
-            <a:ext cx="10561320" cy="731520"/>
-          </a:xfrm>
-          <a:prstGeom prst="rect">
-            <a:avLst/>
-          </a:prstGeom>
-          <a:noFill/>
-          <a:ln/>
-        </p:spPr>
-        <p:txBody>
-          <a:bodyPr wrap="square" lIns="0" tIns="0" rIns="0" bIns="0" rtlCol="0" anchor="ctr"/>
-          <a:lstStyle/>
-          <a:p>
-            <a:pPr indent="0" marL="0">
-              <a:buNone/>
-            </a:pPr>
-            <a:r>
-              <a:rPr lang="en-US" sz="1600" dirty="0">
-                <a:solidFill>
-                  <a:schemeClr val="bg1"/>
-                </a:solidFill>
-              </a:rPr>
-              <a:t>O código é o mesmo nos dois e-mails de propósito: o aluno apresenta o cupom e a empresa confere com o código que recebeu.</a:t>
-            </a:r>
-            <a:endParaRPr lang="en-US" sz="1600" dirty="0"/>
+              <a:t>E-mails recebidos no Gmail durante o teste</a:t>
+            </a:r>
+            <a:endParaRPr lang="en-US" sz="1400" dirty="0"/>
           </a:p>
         </p:txBody>
       </p:sp>
@@ -9144,7 +8787,7 @@
       </p:sp>
       <p:sp>
         <p:nvSpPr>
-          <p:cNvPr id="3" name="cartao-67"/>
+          <p:cNvPr id="3" name="cartao-56"/>
           <p:cNvSpPr/>
           <p:nvPr/>
         </p:nvSpPr>
@@ -9166,7 +8809,7 @@
       </p:sp>
       <p:sp>
         <p:nvSpPr>
-          <p:cNvPr id="4" name="marcador-68"/>
+          <p:cNvPr id="4" name="marcador-57"/>
           <p:cNvSpPr/>
           <p:nvPr/>
         </p:nvSpPr>
@@ -9186,7 +8829,7 @@
       </p:sp>
       <p:sp>
         <p:nvSpPr>
-          <p:cNvPr id="5" name="texto-69"/>
+          <p:cNvPr id="5" name="texto-58"/>
           <p:cNvSpPr txBox="1"/>
           <p:nvPr/>
         </p:nvSpPr>
@@ -9222,7 +8865,7 @@
       </p:sp>
       <p:sp>
         <p:nvSpPr>
-          <p:cNvPr id="6" name="texto-70"/>
+          <p:cNvPr id="6" name="texto-59"/>
           <p:cNvSpPr txBox="1"/>
           <p:nvPr/>
         </p:nvSpPr>
@@ -9258,7 +8901,7 @@
       </p:sp>
       <p:sp>
         <p:nvSpPr>
-          <p:cNvPr id="7" name="texto-71"/>
+          <p:cNvPr id="7" name="texto-60"/>
           <p:cNvSpPr txBox="1"/>
           <p:nvPr/>
         </p:nvSpPr>
@@ -9294,7 +8937,7 @@
       </p:sp>
       <p:sp>
         <p:nvSpPr>
-          <p:cNvPr id="8" name="cartao-72"/>
+          <p:cNvPr id="8" name="cartao-61"/>
           <p:cNvSpPr/>
           <p:nvPr/>
         </p:nvSpPr>
@@ -9316,7 +8959,7 @@
       </p:sp>
       <p:sp>
         <p:nvSpPr>
-          <p:cNvPr id="9" name="marcador-73"/>
+          <p:cNvPr id="9" name="marcador-62"/>
           <p:cNvSpPr/>
           <p:nvPr/>
         </p:nvSpPr>
@@ -9336,7 +8979,7 @@
       </p:sp>
       <p:sp>
         <p:nvSpPr>
-          <p:cNvPr id="10" name="texto-74"/>
+          <p:cNvPr id="10" name="texto-63"/>
           <p:cNvSpPr txBox="1"/>
           <p:nvPr/>
         </p:nvSpPr>
@@ -9372,7 +9015,7 @@
       </p:sp>
       <p:sp>
         <p:nvSpPr>
-          <p:cNvPr id="11" name="texto-75"/>
+          <p:cNvPr id="11" name="texto-64"/>
           <p:cNvSpPr txBox="1"/>
           <p:nvPr/>
         </p:nvSpPr>
@@ -9408,7 +9051,7 @@
       </p:sp>
       <p:sp>
         <p:nvSpPr>
-          <p:cNvPr id="12" name="texto-76"/>
+          <p:cNvPr id="12" name="texto-65"/>
           <p:cNvSpPr txBox="1"/>
           <p:nvPr/>
         </p:nvSpPr>
@@ -9444,7 +9087,7 @@
       </p:sp>
       <p:sp>
         <p:nvSpPr>
-          <p:cNvPr id="13" name="cartao-77"/>
+          <p:cNvPr id="13" name="cartao-66"/>
           <p:cNvSpPr/>
           <p:nvPr/>
         </p:nvSpPr>
@@ -9466,7 +9109,7 @@
       </p:sp>
       <p:sp>
         <p:nvSpPr>
-          <p:cNvPr id="14" name="marcador-78"/>
+          <p:cNvPr id="14" name="marcador-67"/>
           <p:cNvSpPr/>
           <p:nvPr/>
         </p:nvSpPr>
@@ -9486,7 +9129,7 @@
       </p:sp>
       <p:sp>
         <p:nvSpPr>
-          <p:cNvPr id="15" name="texto-79"/>
+          <p:cNvPr id="15" name="texto-68"/>
           <p:cNvSpPr txBox="1"/>
           <p:nvPr/>
         </p:nvSpPr>
@@ -9522,7 +9165,7 @@
       </p:sp>
       <p:sp>
         <p:nvSpPr>
-          <p:cNvPr id="16" name="texto-80"/>
+          <p:cNvPr id="16" name="texto-69"/>
           <p:cNvSpPr txBox="1"/>
           <p:nvPr/>
         </p:nvSpPr>
@@ -9558,7 +9201,7 @@
       </p:sp>
       <p:sp>
         <p:nvSpPr>
-          <p:cNvPr id="17" name="texto-81"/>
+          <p:cNvPr id="17" name="texto-70"/>
           <p:cNvSpPr txBox="1"/>
           <p:nvPr/>
         </p:nvSpPr>
@@ -9594,7 +9237,7 @@
       </p:sp>
       <p:sp>
         <p:nvSpPr>
-          <p:cNvPr id="18" name="cartao-82"/>
+          <p:cNvPr id="18" name="cartao-71"/>
           <p:cNvSpPr/>
           <p:nvPr/>
         </p:nvSpPr>
@@ -9616,7 +9259,7 @@
       </p:sp>
       <p:sp>
         <p:nvSpPr>
-          <p:cNvPr id="19" name="marcador-83"/>
+          <p:cNvPr id="19" name="marcador-72"/>
           <p:cNvSpPr/>
           <p:nvPr/>
         </p:nvSpPr>
@@ -9636,7 +9279,7 @@
       </p:sp>
       <p:sp>
         <p:nvSpPr>
-          <p:cNvPr id="20" name="texto-84"/>
+          <p:cNvPr id="20" name="texto-73"/>
           <p:cNvSpPr txBox="1"/>
           <p:nvPr/>
         </p:nvSpPr>
@@ -9672,7 +9315,7 @@
       </p:sp>
       <p:sp>
         <p:nvSpPr>
-          <p:cNvPr id="21" name="texto-85"/>
+          <p:cNvPr id="21" name="texto-74"/>
           <p:cNvSpPr txBox="1"/>
           <p:nvPr/>
         </p:nvSpPr>
@@ -9708,7 +9351,7 @@
       </p:sp>
       <p:sp>
         <p:nvSpPr>
-          <p:cNvPr id="22" name="texto-86"/>
+          <p:cNvPr id="22" name="texto-75"/>
           <p:cNvSpPr txBox="1"/>
           <p:nvPr/>
         </p:nvSpPr>
@@ -9744,7 +9387,7 @@
       </p:sp>
       <p:sp>
         <p:nvSpPr>
-          <p:cNvPr id="23" name="cartao-87"/>
+          <p:cNvPr id="23" name="cartao-76"/>
           <p:cNvSpPr/>
           <p:nvPr/>
         </p:nvSpPr>
@@ -9766,7 +9409,7 @@
       </p:sp>
       <p:sp>
         <p:nvSpPr>
-          <p:cNvPr id="24" name="marcador-88"/>
+          <p:cNvPr id="24" name="marcador-77"/>
           <p:cNvSpPr/>
           <p:nvPr/>
         </p:nvSpPr>
@@ -9786,7 +9429,7 @@
       </p:sp>
       <p:sp>
         <p:nvSpPr>
-          <p:cNvPr id="25" name="texto-89"/>
+          <p:cNvPr id="25" name="texto-78"/>
           <p:cNvSpPr txBox="1"/>
           <p:nvPr/>
         </p:nvSpPr>
@@ -9822,7 +9465,7 @@
       </p:sp>
       <p:sp>
         <p:nvSpPr>
-          <p:cNvPr id="26" name="texto-90"/>
+          <p:cNvPr id="26" name="texto-79"/>
           <p:cNvSpPr txBox="1"/>
           <p:nvPr/>
         </p:nvSpPr>
@@ -9858,7 +9501,7 @@
       </p:sp>
       <p:sp>
         <p:nvSpPr>
-          <p:cNvPr id="27" name="texto-91"/>
+          <p:cNvPr id="27" name="texto-80"/>
           <p:cNvSpPr txBox="1"/>
           <p:nvPr/>
         </p:nvSpPr>
@@ -10002,7 +9645,7 @@
       </p:sp>
       <p:sp>
         <p:nvSpPr>
-          <p:cNvPr id="3" name="etiqueta-92"/>
+          <p:cNvPr id="3" name="etiqueta-81"/>
           <p:cNvSpPr/>
           <p:nvPr/>
         </p:nvSpPr>
@@ -10024,7 +9667,7 @@
       </p:sp>
       <p:sp>
         <p:nvSpPr>
-          <p:cNvPr id="4" name="texto-93"/>
+          <p:cNvPr id="4" name="texto-82"/>
           <p:cNvSpPr txBox="1"/>
           <p:nvPr/>
         </p:nvSpPr>
@@ -10060,7 +9703,7 @@
       </p:sp>
       <p:sp>
         <p:nvSpPr>
-          <p:cNvPr id="5" name="texto-94"/>
+          <p:cNvPr id="5" name="texto-83"/>
           <p:cNvSpPr txBox="1"/>
           <p:nvPr/>
         </p:nvSpPr>
@@ -10096,7 +9739,7 @@
       </p:sp>
       <p:sp>
         <p:nvSpPr>
-          <p:cNvPr id="6" name="texto-95"/>
+          <p:cNvPr id="6" name="texto-84"/>
           <p:cNvSpPr txBox="1"/>
           <p:nvPr/>
         </p:nvSpPr>
@@ -10132,7 +9775,7 @@
       </p:sp>
       <p:sp>
         <p:nvSpPr>
-          <p:cNvPr id="7" name="texto-96"/>
+          <p:cNvPr id="7" name="texto-85"/>
           <p:cNvSpPr txBox="1"/>
           <p:nvPr/>
         </p:nvSpPr>
@@ -10168,7 +9811,7 @@
       </p:sp>
       <p:sp>
         <p:nvSpPr>
-          <p:cNvPr id="8" name="texto-97"/>
+          <p:cNvPr id="8" name="texto-86"/>
           <p:cNvSpPr txBox="1"/>
           <p:nvPr/>
         </p:nvSpPr>
@@ -10266,7 +9909,7 @@
       </p:sp>
       <p:sp>
         <p:nvSpPr>
-          <p:cNvPr id="9" name="painel-codigo-98"/>
+          <p:cNvPr id="9" name="painel-codigo-87"/>
           <p:cNvSpPr/>
           <p:nvPr/>
         </p:nvSpPr>
@@ -10288,7 +9931,7 @@
       </p:sp>
       <p:sp>
         <p:nvSpPr>
-          <p:cNvPr id="10" name="texto-99"/>
+          <p:cNvPr id="10" name="texto-88"/>
           <p:cNvSpPr txBox="1"/>
           <p:nvPr/>
         </p:nvSpPr>
@@ -10327,7 +9970,7 @@
       </p:sp>
       <p:sp>
         <p:nvSpPr>
-          <p:cNvPr id="11" name="texto-100"/>
+          <p:cNvPr id="11" name="texto-89"/>
           <p:cNvSpPr txBox="1"/>
           <p:nvPr/>
         </p:nvSpPr>
@@ -10713,7 +10356,7 @@
       </p:sp>
       <p:sp>
         <p:nvSpPr>
-          <p:cNvPr id="3" name="etiqueta-101"/>
+          <p:cNvPr id="3" name="etiqueta-90"/>
           <p:cNvSpPr/>
           <p:nvPr/>
         </p:nvSpPr>
@@ -10735,7 +10378,7 @@
       </p:sp>
       <p:sp>
         <p:nvSpPr>
-          <p:cNvPr id="4" name="texto-102"/>
+          <p:cNvPr id="4" name="texto-91"/>
           <p:cNvSpPr txBox="1"/>
           <p:nvPr/>
         </p:nvSpPr>
@@ -10771,7 +10414,7 @@
       </p:sp>
       <p:sp>
         <p:nvSpPr>
-          <p:cNvPr id="5" name="texto-103"/>
+          <p:cNvPr id="5" name="texto-92"/>
           <p:cNvSpPr txBox="1"/>
           <p:nvPr/>
         </p:nvSpPr>
@@ -10807,7 +10450,7 @@
       </p:sp>
       <p:sp>
         <p:nvSpPr>
-          <p:cNvPr id="6" name="texto-104"/>
+          <p:cNvPr id="6" name="texto-93"/>
           <p:cNvSpPr txBox="1"/>
           <p:nvPr/>
         </p:nvSpPr>
@@ -10843,7 +10486,7 @@
       </p:sp>
       <p:sp>
         <p:nvSpPr>
-          <p:cNvPr id="7" name="texto-105"/>
+          <p:cNvPr id="7" name="texto-94"/>
           <p:cNvSpPr txBox="1"/>
           <p:nvPr/>
         </p:nvSpPr>
@@ -10879,7 +10522,7 @@
       </p:sp>
       <p:sp>
         <p:nvSpPr>
-          <p:cNvPr id="8" name="texto-106"/>
+          <p:cNvPr id="8" name="texto-95"/>
           <p:cNvSpPr txBox="1"/>
           <p:nvPr/>
         </p:nvSpPr>
@@ -10977,7 +10620,7 @@
       </p:sp>
       <p:sp>
         <p:nvSpPr>
-          <p:cNvPr id="9" name="painel-codigo-107"/>
+          <p:cNvPr id="9" name="painel-codigo-96"/>
           <p:cNvSpPr/>
           <p:nvPr/>
         </p:nvSpPr>
@@ -10999,7 +10642,7 @@
       </p:sp>
       <p:sp>
         <p:nvSpPr>
-          <p:cNvPr id="10" name="texto-108"/>
+          <p:cNvPr id="10" name="texto-97"/>
           <p:cNvSpPr txBox="1"/>
           <p:nvPr/>
         </p:nvSpPr>
@@ -11038,7 +10681,7 @@
       </p:sp>
       <p:sp>
         <p:nvSpPr>
-          <p:cNvPr id="11" name="texto-109"/>
+          <p:cNvPr id="11" name="texto-98"/>
           <p:cNvSpPr txBox="1"/>
           <p:nvPr/>
         </p:nvSpPr>
@@ -11134,7 +10777,7 @@
       </p:sp>
       <p:sp>
         <p:nvSpPr>
-          <p:cNvPr id="12" name="painel-codigo-110"/>
+          <p:cNvPr id="12" name="painel-codigo-99"/>
           <p:cNvSpPr/>
           <p:nvPr/>
         </p:nvSpPr>
@@ -11156,7 +10799,7 @@
       </p:sp>
       <p:sp>
         <p:nvSpPr>
-          <p:cNvPr id="13" name="texto-111"/>
+          <p:cNvPr id="13" name="texto-100"/>
           <p:cNvSpPr txBox="1"/>
           <p:nvPr/>
         </p:nvSpPr>
@@ -11195,7 +10838,7 @@
       </p:sp>
       <p:sp>
         <p:nvSpPr>
-          <p:cNvPr id="14" name="texto-112"/>
+          <p:cNvPr id="14" name="texto-101"/>
           <p:cNvSpPr txBox="1"/>
           <p:nvPr/>
         </p:nvSpPr>
@@ -11234,7 +10877,7 @@
       </p:sp>
       <p:sp>
         <p:nvSpPr>
-          <p:cNvPr id="15" name="painel-codigo-113"/>
+          <p:cNvPr id="15" name="painel-codigo-102"/>
           <p:cNvSpPr/>
           <p:nvPr/>
         </p:nvSpPr>
@@ -11256,7 +10899,7 @@
       </p:sp>
       <p:sp>
         <p:nvSpPr>
-          <p:cNvPr id="16" name="texto-114"/>
+          <p:cNvPr id="16" name="texto-103"/>
           <p:cNvSpPr txBox="1"/>
           <p:nvPr/>
         </p:nvSpPr>
@@ -11295,7 +10938,7 @@
       </p:sp>
       <p:sp>
         <p:nvSpPr>
-          <p:cNvPr id="17" name="texto-115"/>
+          <p:cNvPr id="17" name="texto-104"/>
           <p:cNvSpPr txBox="1"/>
           <p:nvPr/>
         </p:nvSpPr>

</xml_diff>